<commit_message>
fix(retrieval): enforce exact smoke sources
</commit_message>
<xml_diff>
--- a/tests/e2e/fixtures/pgb-sharepoint/bibliotheek/01 Vergaderstukken/2026-10 Bestuursvergadering/PGB354-PPT-001-Kwartaalplanning-oktober.pptx
+++ b/tests/e2e/fixtures/pgb-sharepoint/bibliotheek/01 Vergaderstukken/2026-10 Bestuursvergadering/PGB354-PPT-001-Kwartaalplanning-oktober.pptx
@@ -2,16 +2,16 @@
 <file path=ppt/presentation.xml><?xml version="1.0" encoding="utf-8"?>
 <p:presentation xmlns:p="http://schemas.openxmlformats.org/presentationml/2006/main">
   <p:sldMasterIdLst>
-    <p:sldMasterId xmlns:r="http://schemas.openxmlformats.org/officeDocument/2006/relationships" id="2147483648" r:id="R56ff242aa38c4a7f"/>
+    <p:sldMasterId xmlns:r="http://schemas.openxmlformats.org/officeDocument/2006/relationships" id="2147483648" r:id="Rf1f292247bf0499a"/>
   </p:sldMasterIdLst>
   <p:notesMasterIdLst>
-    <p:notesMasterId xmlns:r="http://schemas.openxmlformats.org/officeDocument/2006/relationships" r:id="R8e0a696967d8471e"/>
+    <p:notesMasterId xmlns:r="http://schemas.openxmlformats.org/officeDocument/2006/relationships" r:id="R152f933b838d43a2"/>
   </p:notesMasterIdLst>
   <p:sldIdLst>
-    <p:sldId xmlns:r="http://schemas.openxmlformats.org/officeDocument/2006/relationships" id="256" r:id="R0e800e61da7242ca"/>
-    <p:sldId xmlns:r="http://schemas.openxmlformats.org/officeDocument/2006/relationships" id="257" r:id="R5b29babc81284db8"/>
-    <p:sldId xmlns:r="http://schemas.openxmlformats.org/officeDocument/2006/relationships" id="258" r:id="R5713f361362741ec"/>
-    <p:sldId xmlns:r="http://schemas.openxmlformats.org/officeDocument/2006/relationships" id="259" r:id="R95da4e299f094bf8"/>
+    <p:sldId xmlns:r="http://schemas.openxmlformats.org/officeDocument/2006/relationships" id="256" r:id="R19cc91ecfeb14bc0"/>
+    <p:sldId xmlns:r="http://schemas.openxmlformats.org/officeDocument/2006/relationships" id="257" r:id="Rc2e5fdcfd6d547cc"/>
+    <p:sldId xmlns:r="http://schemas.openxmlformats.org/officeDocument/2006/relationships" id="258" r:id="R7791ed464826496f"/>
+    <p:sldId xmlns:r="http://schemas.openxmlformats.org/officeDocument/2006/relationships" id="259" r:id="R1c90c60b47c94d28"/>
   </p:sldIdLst>
   <p:sldSz cx="12192000" cy="6858000"/>
   <p:notesSz cx="6858000" cy="9144000"/>
@@ -723,7 +723,7 @@
   </p:cSld>
   <p:clrMap bg1="lt1" tx1="dk1" bg2="lt2" tx2="dk2" accent1="accent1" accent2="accent2" accent3="accent3" accent4="accent4" accent5="accent5" accent6="accent6" hlink="hlink" folHlink="folHlink"/>
   <p:sldLayoutIdLst>
-    <p:sldLayoutId xmlns:r="http://schemas.openxmlformats.org/officeDocument/2006/relationships" id="2147483649" r:id="R79586a83374347aa"/>
+    <p:sldLayoutId xmlns:r="http://schemas.openxmlformats.org/officeDocument/2006/relationships" id="2147483649" r:id="Rad2b5c87b1c84026"/>
   </p:sldLayoutIdLst>
   <p:txStyles>
     <p:titleStyle>
@@ -1274,7 +1274,7 @@
           <p:cNvPr id="5" name="">
             <a:extLst xmlns:a="http://schemas.openxmlformats.org/drawingml/2006/main">
               <a:ext uri="{FF2B5EF4-FFF2-40B4-BE49-F238E27FC236}">
-                <a16:creationId xmlns:a16="http://schemas.microsoft.com/office/drawing/2014/main" id="{4BFDEF18-D341-41E0-BC7A-85094AFA9340}"/>
+                <a16:creationId xmlns:a16="http://schemas.microsoft.com/office/drawing/2014/main" id="{E5BDE8DF-7DB3-4637-9A07-A59BB49DF804}"/>
               </a:ext>
             </a:extLst>
           </p:cNvPr>
@@ -1331,7 +1331,7 @@
           <p:cNvPr id="2" name="">
             <a:extLst xmlns:a="http://schemas.openxmlformats.org/drawingml/2006/main">
               <a:ext uri="{FF2B5EF4-FFF2-40B4-BE49-F238E27FC236}">
-                <a16:creationId xmlns:a16="http://schemas.microsoft.com/office/drawing/2014/main" id="{1054EC87-E51C-4CA4-8069-CC699EACBBA5}"/>
+                <a16:creationId xmlns:a16="http://schemas.microsoft.com/office/drawing/2014/main" id="{FE65DAEF-B712-4E7C-B99A-6044BA6B7A17}"/>
               </a:ext>
             </a:extLst>
           </p:cNvPr>
@@ -1388,7 +1388,7 @@
           <p:cNvPr id="3" name="">
             <a:extLst xmlns:a="http://schemas.openxmlformats.org/drawingml/2006/main">
               <a:ext uri="{FF2B5EF4-FFF2-40B4-BE49-F238E27FC236}">
-                <a16:creationId xmlns:a16="http://schemas.microsoft.com/office/drawing/2014/main" id="{EF52B7CF-18A7-4EEA-AEF1-02DDD2FF2A4C}"/>
+                <a16:creationId xmlns:a16="http://schemas.microsoft.com/office/drawing/2014/main" id="{C7E1E5E3-1C75-4371-B0D3-2CF5638057F0}"/>
               </a:ext>
             </a:extLst>
           </p:cNvPr>
@@ -1445,7 +1445,7 @@
           <p:cNvPr id="4" name="">
             <a:extLst xmlns:a="http://schemas.openxmlformats.org/drawingml/2006/main">
               <a:ext uri="{FF2B5EF4-FFF2-40B4-BE49-F238E27FC236}">
-                <a16:creationId xmlns:a16="http://schemas.microsoft.com/office/drawing/2014/main" id="{65A4275A-FD9B-492C-8102-F62172825524}"/>
+                <a16:creationId xmlns:a16="http://schemas.microsoft.com/office/drawing/2014/main" id="{149AAFAA-D999-4D48-831B-C09BAD5CF649}"/>
               </a:ext>
             </a:extLst>
           </p:cNvPr>
@@ -1546,7 +1546,7 @@
     </p:spTree>
     <p:extLst>
       <p:ext uri="{BB962C8B-B14F-4D97-AF65-F5344CB8AC3E}">
-        <p14:creationId xmlns:p14="http://schemas.microsoft.com/office/powerpoint/2010/main" val="1971050843"/>
+        <p14:creationId xmlns:p14="http://schemas.microsoft.com/office/powerpoint/2010/main" val="505080616"/>
       </p:ext>
     </p:extLst>
   </p:cSld>
@@ -1577,7 +1577,7 @@
           <p:cNvPr id="9" name="">
             <a:extLst xmlns:a="http://schemas.openxmlformats.org/drawingml/2006/main">
               <a:ext uri="{FF2B5EF4-FFF2-40B4-BE49-F238E27FC236}">
-                <a16:creationId xmlns:a16="http://schemas.microsoft.com/office/drawing/2014/main" id="{44235EEF-BB7E-4561-9B62-14F5D637FDCC}"/>
+                <a16:creationId xmlns:a16="http://schemas.microsoft.com/office/drawing/2014/main" id="{53ADE607-0463-4B85-B578-44B145E53F31}"/>
               </a:ext>
             </a:extLst>
           </p:cNvPr>
@@ -1634,7 +1634,7 @@
           <p:cNvPr id="2" name="">
             <a:extLst xmlns:a="http://schemas.openxmlformats.org/drawingml/2006/main">
               <a:ext uri="{FF2B5EF4-FFF2-40B4-BE49-F238E27FC236}">
-                <a16:creationId xmlns:a16="http://schemas.microsoft.com/office/drawing/2014/main" id="{3BD684B0-57D1-4EF5-A473-FA7B4EDD0FBD}"/>
+                <a16:creationId xmlns:a16="http://schemas.microsoft.com/office/drawing/2014/main" id="{DEBD86C4-89A8-488F-83C6-797D7D1CE87B}"/>
               </a:ext>
             </a:extLst>
           </p:cNvPr>
@@ -1691,7 +1691,7 @@
           <p:cNvPr id="3" name="">
             <a:extLst xmlns:a="http://schemas.openxmlformats.org/drawingml/2006/main">
               <a:ext uri="{FF2B5EF4-FFF2-40B4-BE49-F238E27FC236}">
-                <a16:creationId xmlns:a16="http://schemas.microsoft.com/office/drawing/2014/main" id="{28F484C4-C8A8-4227-B8C4-19F7FC94935D}"/>
+                <a16:creationId xmlns:a16="http://schemas.microsoft.com/office/drawing/2014/main" id="{032D7CE3-E9E8-41DD-B6F0-1B9AABD28E8C}"/>
               </a:ext>
             </a:extLst>
           </p:cNvPr>
@@ -1748,7 +1748,7 @@
           <p:cNvPr id="4" name="">
             <a:extLst xmlns:a="http://schemas.openxmlformats.org/drawingml/2006/main">
               <a:ext uri="{FF2B5EF4-FFF2-40B4-BE49-F238E27FC236}">
-                <a16:creationId xmlns:a16="http://schemas.microsoft.com/office/drawing/2014/main" id="{4723AF80-C1C6-4CC3-8917-BE331E6865EC}"/>
+                <a16:creationId xmlns:a16="http://schemas.microsoft.com/office/drawing/2014/main" id="{B20F39DC-3BA1-4CF8-BE7B-22E665FEE8B5}"/>
               </a:ext>
             </a:extLst>
           </p:cNvPr>
@@ -1805,7 +1805,7 @@
           <p:cNvPr id="5" name="">
             <a:extLst xmlns:a="http://schemas.openxmlformats.org/drawingml/2006/main">
               <a:ext uri="{FF2B5EF4-FFF2-40B4-BE49-F238E27FC236}">
-                <a16:creationId xmlns:a16="http://schemas.microsoft.com/office/drawing/2014/main" id="{40FB3FD0-C3F4-4E4A-BAA9-775967297552}"/>
+                <a16:creationId xmlns:a16="http://schemas.microsoft.com/office/drawing/2014/main" id="{A146146D-D045-414A-9DE9-00145D8CEB10}"/>
               </a:ext>
             </a:extLst>
           </p:cNvPr>
@@ -1862,7 +1862,7 @@
           <p:cNvPr id="6" name="">
             <a:extLst xmlns:a="http://schemas.openxmlformats.org/drawingml/2006/main">
               <a:ext uri="{FF2B5EF4-FFF2-40B4-BE49-F238E27FC236}">
-                <a16:creationId xmlns:a16="http://schemas.microsoft.com/office/drawing/2014/main" id="{F320848C-0714-4B14-B4CF-7ADFC35DE6E6}"/>
+                <a16:creationId xmlns:a16="http://schemas.microsoft.com/office/drawing/2014/main" id="{1AAD1958-2C67-42A4-BDEA-0581D1E3EA4F}"/>
               </a:ext>
             </a:extLst>
           </p:cNvPr>
@@ -1919,7 +1919,7 @@
           <p:cNvPr id="7" name="">
             <a:extLst xmlns:a="http://schemas.openxmlformats.org/drawingml/2006/main">
               <a:ext uri="{FF2B5EF4-FFF2-40B4-BE49-F238E27FC236}">
-                <a16:creationId xmlns:a16="http://schemas.microsoft.com/office/drawing/2014/main" id="{0EF50CF9-3D02-4B9A-BA61-23B36FB2606D}"/>
+                <a16:creationId xmlns:a16="http://schemas.microsoft.com/office/drawing/2014/main" id="{1061AA67-40AB-42FA-B783-8FF091DE8E3E}"/>
               </a:ext>
             </a:extLst>
           </p:cNvPr>
@@ -1976,7 +1976,7 @@
           <p:cNvPr id="8" name="">
             <a:extLst xmlns:a="http://schemas.openxmlformats.org/drawingml/2006/main">
               <a:ext uri="{FF2B5EF4-FFF2-40B4-BE49-F238E27FC236}">
-                <a16:creationId xmlns:a16="http://schemas.microsoft.com/office/drawing/2014/main" id="{03C244C3-D1D1-407E-A3E9-71E28D8C7374}"/>
+                <a16:creationId xmlns:a16="http://schemas.microsoft.com/office/drawing/2014/main" id="{01ACB4C8-2287-442E-80D7-6566A43BCEF2}"/>
               </a:ext>
             </a:extLst>
           </p:cNvPr>
@@ -2031,7 +2031,7 @@
     </p:spTree>
     <p:extLst>
       <p:ext uri="{BB962C8B-B14F-4D97-AF65-F5344CB8AC3E}">
-        <p14:creationId xmlns:p14="http://schemas.microsoft.com/office/powerpoint/2010/main" val="909715770"/>
+        <p14:creationId xmlns:p14="http://schemas.microsoft.com/office/powerpoint/2010/main" val="1543725172"/>
       </p:ext>
     </p:extLst>
   </p:cSld>
@@ -2062,7 +2062,7 @@
           <p:cNvPr id="6" name="">
             <a:extLst xmlns:a="http://schemas.openxmlformats.org/drawingml/2006/main">
               <a:ext uri="{FF2B5EF4-FFF2-40B4-BE49-F238E27FC236}">
-                <a16:creationId xmlns:a16="http://schemas.microsoft.com/office/drawing/2014/main" id="{43D71C06-D1B7-4E0A-B63F-E8598B8E06E3}"/>
+                <a16:creationId xmlns:a16="http://schemas.microsoft.com/office/drawing/2014/main" id="{A99180CB-29C5-41E3-B8C1-06B4C571B5EC}"/>
               </a:ext>
             </a:extLst>
           </p:cNvPr>
@@ -2119,7 +2119,7 @@
           <p:cNvPr id="2" name="">
             <a:extLst xmlns:a="http://schemas.openxmlformats.org/drawingml/2006/main">
               <a:ext uri="{FF2B5EF4-FFF2-40B4-BE49-F238E27FC236}">
-                <a16:creationId xmlns:a16="http://schemas.microsoft.com/office/drawing/2014/main" id="{3EF90BCC-8B6F-4B9F-86C8-CCB55980124E}"/>
+                <a16:creationId xmlns:a16="http://schemas.microsoft.com/office/drawing/2014/main" id="{8B3B800E-5D29-49FE-B134-C0C93AA870E0}"/>
               </a:ext>
             </a:extLst>
           </p:cNvPr>
@@ -2176,7 +2176,7 @@
           <p:cNvPr id="3" name="">
             <a:extLst xmlns:a="http://schemas.openxmlformats.org/drawingml/2006/main">
               <a:ext uri="{FF2B5EF4-FFF2-40B4-BE49-F238E27FC236}">
-                <a16:creationId xmlns:a16="http://schemas.microsoft.com/office/drawing/2014/main" id="{81237729-9F07-46DD-AE1F-8B7DC38CA8D9}"/>
+                <a16:creationId xmlns:a16="http://schemas.microsoft.com/office/drawing/2014/main" id="{415889E1-E300-48C3-A30D-81C81C6346C1}"/>
               </a:ext>
             </a:extLst>
           </p:cNvPr>
@@ -2233,7 +2233,7 @@
           <p:cNvPr id="4" name="">
             <a:extLst xmlns:a="http://schemas.openxmlformats.org/drawingml/2006/main">
               <a:ext uri="{FF2B5EF4-FFF2-40B4-BE49-F238E27FC236}">
-                <a16:creationId xmlns:a16="http://schemas.microsoft.com/office/drawing/2014/main" id="{706DCA8F-D70E-415E-83D2-F8DFA22B449F}"/>
+                <a16:creationId xmlns:a16="http://schemas.microsoft.com/office/drawing/2014/main" id="{BE963E2A-E3CA-4D48-86C1-AE9BF4498BC6}"/>
               </a:ext>
             </a:extLst>
           </p:cNvPr>
@@ -2290,7 +2290,7 @@
           <p:cNvPr id="5" name="">
             <a:extLst xmlns:a="http://schemas.openxmlformats.org/drawingml/2006/main">
               <a:ext uri="{FF2B5EF4-FFF2-40B4-BE49-F238E27FC236}">
-                <a16:creationId xmlns:a16="http://schemas.microsoft.com/office/drawing/2014/main" id="{93791C7D-D5C3-4199-BA9B-BF063C9350D7}"/>
+                <a16:creationId xmlns:a16="http://schemas.microsoft.com/office/drawing/2014/main" id="{5D292BEB-EC32-42CD-93C6-243387BBA2BE}"/>
               </a:ext>
             </a:extLst>
           </p:cNvPr>
@@ -2337,7 +2337,7 @@
                 <a:ea typeface="Helvetica Neue"/>
                 <a:cs typeface="Helvetica Neue"/>
               </a:rPr>
-              <a:t>Verwachte locator: dia 3. Een fondsbrede vraag combineert dit feit met Koraalmaat 47 uit PGB354-DOC-001.</a:t>
+              <a:t>Verwachte locator: dia 3. Een fondsbrede vraag combineert dit feit met de hersteltermijn uit PGB354-DOC-001.</a:t>
             </a:r>
           </a:p>
         </p:txBody>
@@ -2345,7 +2345,7 @@
     </p:spTree>
     <p:extLst>
       <p:ext uri="{BB962C8B-B14F-4D97-AF65-F5344CB8AC3E}">
-        <p14:creationId xmlns:p14="http://schemas.microsoft.com/office/powerpoint/2010/main" val="380691627"/>
+        <p14:creationId xmlns:p14="http://schemas.microsoft.com/office/powerpoint/2010/main" val="978687728"/>
       </p:ext>
     </p:extLst>
   </p:cSld>
@@ -2376,7 +2376,7 @@
           <p:cNvPr id="11" name="">
             <a:extLst xmlns:a="http://schemas.openxmlformats.org/drawingml/2006/main">
               <a:ext uri="{FF2B5EF4-FFF2-40B4-BE49-F238E27FC236}">
-                <a16:creationId xmlns:a16="http://schemas.microsoft.com/office/drawing/2014/main" id="{595424B6-8207-4F71-A245-9005BA68E828}"/>
+                <a16:creationId xmlns:a16="http://schemas.microsoft.com/office/drawing/2014/main" id="{D062F1DB-6BC9-4322-9265-915BDAC26FE7}"/>
               </a:ext>
             </a:extLst>
           </p:cNvPr>
@@ -2433,7 +2433,7 @@
           <p:cNvPr id="2" name="">
             <a:extLst xmlns:a="http://schemas.openxmlformats.org/drawingml/2006/main">
               <a:ext uri="{FF2B5EF4-FFF2-40B4-BE49-F238E27FC236}">
-                <a16:creationId xmlns:a16="http://schemas.microsoft.com/office/drawing/2014/main" id="{D67D8879-0579-4F35-88AC-D7264978ABA2}"/>
+                <a16:creationId xmlns:a16="http://schemas.microsoft.com/office/drawing/2014/main" id="{A69FF9E6-B0B7-40DD-B294-9D76BB72CF3F}"/>
               </a:ext>
             </a:extLst>
           </p:cNvPr>
@@ -2490,7 +2490,7 @@
           <p:cNvPr id="3" name="">
             <a:extLst xmlns:a="http://schemas.openxmlformats.org/drawingml/2006/main">
               <a:ext uri="{FF2B5EF4-FFF2-40B4-BE49-F238E27FC236}">
-                <a16:creationId xmlns:a16="http://schemas.microsoft.com/office/drawing/2014/main" id="{E1FD2E5F-748E-42F1-BDDE-619F18928425}"/>
+                <a16:creationId xmlns:a16="http://schemas.microsoft.com/office/drawing/2014/main" id="{C467FC71-6B1A-4D16-8486-722BD1EA6C5A}"/>
               </a:ext>
             </a:extLst>
           </p:cNvPr>
@@ -2547,7 +2547,7 @@
           <p:cNvPr id="4" name="">
             <a:extLst xmlns:a="http://schemas.openxmlformats.org/drawingml/2006/main">
               <a:ext uri="{FF2B5EF4-FFF2-40B4-BE49-F238E27FC236}">
-                <a16:creationId xmlns:a16="http://schemas.microsoft.com/office/drawing/2014/main" id="{7E1AD57B-E9DB-46B2-9BF3-DB0C78F2D745}"/>
+                <a16:creationId xmlns:a16="http://schemas.microsoft.com/office/drawing/2014/main" id="{91088E4A-327C-4FB7-8B1C-0B2723E2F784}"/>
               </a:ext>
             </a:extLst>
           </p:cNvPr>
@@ -2604,7 +2604,7 @@
           <p:cNvPr id="5" name="">
             <a:extLst xmlns:a="http://schemas.openxmlformats.org/drawingml/2006/main">
               <a:ext uri="{FF2B5EF4-FFF2-40B4-BE49-F238E27FC236}">
-                <a16:creationId xmlns:a16="http://schemas.microsoft.com/office/drawing/2014/main" id="{90AFF9E4-1FEF-41F5-B0F5-9DFE2AA0FB53}"/>
+                <a16:creationId xmlns:a16="http://schemas.microsoft.com/office/drawing/2014/main" id="{F1612FAE-787B-4D38-BFF2-2B35990C0612}"/>
               </a:ext>
             </a:extLst>
           </p:cNvPr>
@@ -2661,7 +2661,7 @@
           <p:cNvPr id="6" name="">
             <a:extLst xmlns:a="http://schemas.openxmlformats.org/drawingml/2006/main">
               <a:ext uri="{FF2B5EF4-FFF2-40B4-BE49-F238E27FC236}">
-                <a16:creationId xmlns:a16="http://schemas.microsoft.com/office/drawing/2014/main" id="{23188D39-BC09-4F15-B8B9-0464769BDCD9}"/>
+                <a16:creationId xmlns:a16="http://schemas.microsoft.com/office/drawing/2014/main" id="{8A6C86D2-98B9-4203-A085-DA68AC63142A}"/>
               </a:ext>
             </a:extLst>
           </p:cNvPr>
@@ -2718,7 +2718,7 @@
           <p:cNvPr id="7" name="">
             <a:extLst xmlns:a="http://schemas.openxmlformats.org/drawingml/2006/main">
               <a:ext uri="{FF2B5EF4-FFF2-40B4-BE49-F238E27FC236}">
-                <a16:creationId xmlns:a16="http://schemas.microsoft.com/office/drawing/2014/main" id="{8FAB149D-D0BA-479A-B342-606DAD70B04A}"/>
+                <a16:creationId xmlns:a16="http://schemas.microsoft.com/office/drawing/2014/main" id="{E4E5E06A-6609-4FA5-80B9-B1699B499A18}"/>
               </a:ext>
             </a:extLst>
           </p:cNvPr>
@@ -2775,7 +2775,7 @@
           <p:cNvPr id="8" name="">
             <a:extLst xmlns:a="http://schemas.openxmlformats.org/drawingml/2006/main">
               <a:ext uri="{FF2B5EF4-FFF2-40B4-BE49-F238E27FC236}">
-                <a16:creationId xmlns:a16="http://schemas.microsoft.com/office/drawing/2014/main" id="{73ACCDC6-8AA3-4A86-8FBB-B11C0EB576A7}"/>
+                <a16:creationId xmlns:a16="http://schemas.microsoft.com/office/drawing/2014/main" id="{060ABC17-3A6E-442E-8CFA-50C106990BC9}"/>
               </a:ext>
             </a:extLst>
           </p:cNvPr>
@@ -2832,7 +2832,7 @@
           <p:cNvPr id="9" name="">
             <a:extLst xmlns:a="http://schemas.openxmlformats.org/drawingml/2006/main">
               <a:ext uri="{FF2B5EF4-FFF2-40B4-BE49-F238E27FC236}">
-                <a16:creationId xmlns:a16="http://schemas.microsoft.com/office/drawing/2014/main" id="{46505AD1-F8AA-4247-9BFD-7E4092E69D66}"/>
+                <a16:creationId xmlns:a16="http://schemas.microsoft.com/office/drawing/2014/main" id="{1E4EAAB0-BA55-421B-8E2E-BD6A7E3D1B21}"/>
               </a:ext>
             </a:extLst>
           </p:cNvPr>
@@ -2889,7 +2889,7 @@
           <p:cNvPr id="10" name="">
             <a:extLst xmlns:a="http://schemas.openxmlformats.org/drawingml/2006/main">
               <a:ext uri="{FF2B5EF4-FFF2-40B4-BE49-F238E27FC236}">
-                <a16:creationId xmlns:a16="http://schemas.microsoft.com/office/drawing/2014/main" id="{D9A7CF05-5391-4860-B5DB-702297CC166C}"/>
+                <a16:creationId xmlns:a16="http://schemas.microsoft.com/office/drawing/2014/main" id="{4FB13D82-BDC4-4713-B8EF-E7B96B865A0C}"/>
               </a:ext>
             </a:extLst>
           </p:cNvPr>
@@ -2944,7 +2944,7 @@
     </p:spTree>
     <p:extLst>
       <p:ext uri="{BB962C8B-B14F-4D97-AF65-F5344CB8AC3E}">
-        <p14:creationId xmlns:p14="http://schemas.microsoft.com/office/powerpoint/2010/main" val="1592297468"/>
+        <p14:creationId xmlns:p14="http://schemas.microsoft.com/office/powerpoint/2010/main" val="2062475832"/>
       </p:ext>
     </p:extLst>
   </p:cSld>

</xml_diff>